<commit_message>
Still working on monitoring matching.
</commit_message>
<xml_diff>
--- a/docs/monitoring_noMatches.pptx
+++ b/docs/monitoring_noMatches.pptx
@@ -104,7 +104,169 @@
       </a:defRPr>
     </a:lvl9pPr>
   </p:defaultTextStyle>
+  <p:extLst>
+    <p:ext uri="{EFAFB233-063F-42B5-8137-9DF3F51BA10A}">
+      <p15:sldGuideLst xmlns:p15="http://schemas.microsoft.com/office/powerpoint/2012/main"/>
+    </p:ext>
+  </p:extLst>
 </p:presentation>
+</file>
+
+<file path=ppt/revisionInfo.xml><?xml version="1.0" encoding="utf-8"?>
+<p1510:revInfo xmlns:a="http://schemas.openxmlformats.org/drawingml/2006/main" xmlns:r="http://schemas.openxmlformats.org/officeDocument/2006/relationships" xmlns:p1510="http://schemas.microsoft.com/office/powerpoint/2015/10/main">
+  <p1510:revLst>
+    <p1510:client id="{CA455924-F6A1-4942-9F87-A07E1BC0E535}" v="1" dt="2026-07-09T14:03:19.269"/>
+  </p1510:revLst>
+</p1510:revInfo>
+</file>
+
+<file path=ppt/changesInfos/changesInfo1.xml><?xml version="1.0" encoding="utf-8"?>
+<pc:chgInfo xmlns:a="http://schemas.openxmlformats.org/drawingml/2006/main" xmlns:r="http://schemas.openxmlformats.org/officeDocument/2006/relationships" xmlns:ac="http://schemas.microsoft.com/office/drawing/2013/main/command" xmlns:pc="http://schemas.microsoft.com/office/powerpoint/2013/main/command">
+  <pc:docChgLst>
+    <pc:chgData name="DOWTY, PETER (DNR)" userId="01cf875a-4e15-4928-8f93-7a0dfa1efb6b" providerId="ADAL" clId="{E9054DD1-CDF4-4BE2-A4C5-BD4B0395A89E}"/>
+    <pc:docChg chg="undo custSel modSld">
+      <pc:chgData name="DOWTY, PETER (DNR)" userId="01cf875a-4e15-4928-8f93-7a0dfa1efb6b" providerId="ADAL" clId="{E9054DD1-CDF4-4BE2-A4C5-BD4B0395A89E}" dt="2026-07-09T15:26:09.825" v="222" actId="1076"/>
+      <pc:docMkLst>
+        <pc:docMk/>
+      </pc:docMkLst>
+      <pc:sldChg chg="addSp delSp modSp mod">
+        <pc:chgData name="DOWTY, PETER (DNR)" userId="01cf875a-4e15-4928-8f93-7a0dfa1efb6b" providerId="ADAL" clId="{E9054DD1-CDF4-4BE2-A4C5-BD4B0395A89E}" dt="2026-07-09T15:26:09.825" v="222" actId="1076"/>
+        <pc:sldMkLst>
+          <pc:docMk/>
+          <pc:sldMk cId="1915551359" sldId="256"/>
+        </pc:sldMkLst>
+        <pc:spChg chg="add del mod">
+          <ac:chgData name="DOWTY, PETER (DNR)" userId="01cf875a-4e15-4928-8f93-7a0dfa1efb6b" providerId="ADAL" clId="{E9054DD1-CDF4-4BE2-A4C5-BD4B0395A89E}" dt="2026-07-09T15:25:55.406" v="220" actId="478"/>
+          <ac:spMkLst>
+            <pc:docMk/>
+            <pc:sldMk cId="1915551359" sldId="256"/>
+            <ac:spMk id="3" creationId="{261EABBD-98BF-3541-C3CC-F7C23272F635}"/>
+          </ac:spMkLst>
+        </pc:spChg>
+        <pc:spChg chg="add del mod">
+          <ac:chgData name="DOWTY, PETER (DNR)" userId="01cf875a-4e15-4928-8f93-7a0dfa1efb6b" providerId="ADAL" clId="{E9054DD1-CDF4-4BE2-A4C5-BD4B0395A89E}" dt="2026-07-09T15:25:46.322" v="218" actId="478"/>
+          <ac:spMkLst>
+            <pc:docMk/>
+            <pc:sldMk cId="1915551359" sldId="256"/>
+            <ac:spMk id="4" creationId="{E1419D9F-00D5-BA2E-A5ED-D27B02C56953}"/>
+          </ac:spMkLst>
+        </pc:spChg>
+        <pc:spChg chg="mod">
+          <ac:chgData name="DOWTY, PETER (DNR)" userId="01cf875a-4e15-4928-8f93-7a0dfa1efb6b" providerId="ADAL" clId="{E9054DD1-CDF4-4BE2-A4C5-BD4B0395A89E}" dt="2026-07-09T14:12:43.712" v="189" actId="1076"/>
+          <ac:spMkLst>
+            <pc:docMk/>
+            <pc:sldMk cId="1915551359" sldId="256"/>
+            <ac:spMk id="6" creationId="{2DD91F60-6E8D-5392-B36A-D5BA97352332}"/>
+          </ac:spMkLst>
+        </pc:spChg>
+        <pc:spChg chg="del">
+          <ac:chgData name="DOWTY, PETER (DNR)" userId="01cf875a-4e15-4928-8f93-7a0dfa1efb6b" providerId="ADAL" clId="{E9054DD1-CDF4-4BE2-A4C5-BD4B0395A89E}" dt="2026-07-09T13:59:24.022" v="1" actId="478"/>
+          <ac:spMkLst>
+            <pc:docMk/>
+            <pc:sldMk cId="1915551359" sldId="256"/>
+            <ac:spMk id="10" creationId="{46F0BEE4-35FB-907E-6845-2623813284AD}"/>
+          </ac:spMkLst>
+        </pc:spChg>
+        <pc:spChg chg="del">
+          <ac:chgData name="DOWTY, PETER (DNR)" userId="01cf875a-4e15-4928-8f93-7a0dfa1efb6b" providerId="ADAL" clId="{E9054DD1-CDF4-4BE2-A4C5-BD4B0395A89E}" dt="2026-07-09T13:59:24.022" v="1" actId="478"/>
+          <ac:spMkLst>
+            <pc:docMk/>
+            <pc:sldMk cId="1915551359" sldId="256"/>
+            <ac:spMk id="11" creationId="{34A3C746-D7A8-84C1-A7E0-21D276C9840E}"/>
+          </ac:spMkLst>
+        </pc:spChg>
+        <pc:spChg chg="del">
+          <ac:chgData name="DOWTY, PETER (DNR)" userId="01cf875a-4e15-4928-8f93-7a0dfa1efb6b" providerId="ADAL" clId="{E9054DD1-CDF4-4BE2-A4C5-BD4B0395A89E}" dt="2026-07-09T13:59:24.022" v="1" actId="478"/>
+          <ac:spMkLst>
+            <pc:docMk/>
+            <pc:sldMk cId="1915551359" sldId="256"/>
+            <ac:spMk id="20" creationId="{67FA898A-ADB1-BD7A-6D32-D651D2ED7604}"/>
+          </ac:spMkLst>
+        </pc:spChg>
+        <pc:spChg chg="del mod">
+          <ac:chgData name="DOWTY, PETER (DNR)" userId="01cf875a-4e15-4928-8f93-7a0dfa1efb6b" providerId="ADAL" clId="{E9054DD1-CDF4-4BE2-A4C5-BD4B0395A89E}" dt="2026-07-09T14:03:15.027" v="32" actId="478"/>
+          <ac:spMkLst>
+            <pc:docMk/>
+            <pc:sldMk cId="1915551359" sldId="256"/>
+            <ac:spMk id="24" creationId="{FF02E598-D5C0-6007-CF23-974E2CD1FDD7}"/>
+          </ac:spMkLst>
+        </pc:spChg>
+        <pc:spChg chg="del mod">
+          <ac:chgData name="DOWTY, PETER (DNR)" userId="01cf875a-4e15-4928-8f93-7a0dfa1efb6b" providerId="ADAL" clId="{E9054DD1-CDF4-4BE2-A4C5-BD4B0395A89E}" dt="2026-07-09T14:02:46.084" v="30" actId="478"/>
+          <ac:spMkLst>
+            <pc:docMk/>
+            <pc:sldMk cId="1915551359" sldId="256"/>
+            <ac:spMk id="26" creationId="{D22AC38F-7129-62B3-D454-E212F4D7F97C}"/>
+          </ac:spMkLst>
+        </pc:spChg>
+        <pc:picChg chg="add del mod modCrop">
+          <ac:chgData name="DOWTY, PETER (DNR)" userId="01cf875a-4e15-4928-8f93-7a0dfa1efb6b" providerId="ADAL" clId="{E9054DD1-CDF4-4BE2-A4C5-BD4B0395A89E}" dt="2026-07-09T15:26:09.825" v="222" actId="1076"/>
+          <ac:picMkLst>
+            <pc:docMk/>
+            <pc:sldMk cId="1915551359" sldId="256"/>
+            <ac:picMk id="5" creationId="{4479EB1B-6E07-5EEE-EC8B-B76AA89DB1AF}"/>
+          </ac:picMkLst>
+        </pc:picChg>
+        <pc:picChg chg="del">
+          <ac:chgData name="DOWTY, PETER (DNR)" userId="01cf875a-4e15-4928-8f93-7a0dfa1efb6b" providerId="ADAL" clId="{E9054DD1-CDF4-4BE2-A4C5-BD4B0395A89E}" dt="2026-07-09T13:59:21.298" v="0" actId="478"/>
+          <ac:picMkLst>
+            <pc:docMk/>
+            <pc:sldMk cId="1915551359" sldId="256"/>
+            <ac:picMk id="8" creationId="{C1DC4500-D4F5-1B2C-3555-1767960B30A3}"/>
+          </ac:picMkLst>
+        </pc:picChg>
+        <pc:picChg chg="add del mod">
+          <ac:chgData name="DOWTY, PETER (DNR)" userId="01cf875a-4e15-4928-8f93-7a0dfa1efb6b" providerId="ADAL" clId="{E9054DD1-CDF4-4BE2-A4C5-BD4B0395A89E}" dt="2026-07-09T15:25:39.684" v="214" actId="478"/>
+          <ac:picMkLst>
+            <pc:docMk/>
+            <pc:sldMk cId="1915551359" sldId="256"/>
+            <ac:picMk id="13" creationId="{A551E931-F1A6-297A-52B0-612AFC7AD865}"/>
+          </ac:picMkLst>
+        </pc:picChg>
+        <pc:picChg chg="del">
+          <ac:chgData name="DOWTY, PETER (DNR)" userId="01cf875a-4e15-4928-8f93-7a0dfa1efb6b" providerId="ADAL" clId="{E9054DD1-CDF4-4BE2-A4C5-BD4B0395A89E}" dt="2026-07-09T13:59:33.205" v="4" actId="478"/>
+          <ac:picMkLst>
+            <pc:docMk/>
+            <pc:sldMk cId="1915551359" sldId="256"/>
+            <ac:picMk id="16" creationId="{5CEB1410-6BC8-D8C1-F709-4BBC9D2C958C}"/>
+          </ac:picMkLst>
+        </pc:picChg>
+        <pc:picChg chg="add del mod ord">
+          <ac:chgData name="DOWTY, PETER (DNR)" userId="01cf875a-4e15-4928-8f93-7a0dfa1efb6b" providerId="ADAL" clId="{E9054DD1-CDF4-4BE2-A4C5-BD4B0395A89E}" dt="2026-07-09T15:25:40.242" v="216" actId="478"/>
+          <ac:picMkLst>
+            <pc:docMk/>
+            <pc:sldMk cId="1915551359" sldId="256"/>
+            <ac:picMk id="17" creationId="{2E86DFF6-C686-29CA-2818-FBAE36B078A5}"/>
+          </ac:picMkLst>
+        </pc:picChg>
+        <pc:cxnChg chg="add del mod">
+          <ac:chgData name="DOWTY, PETER (DNR)" userId="01cf875a-4e15-4928-8f93-7a0dfa1efb6b" providerId="ADAL" clId="{E9054DD1-CDF4-4BE2-A4C5-BD4B0395A89E}" dt="2026-07-09T15:25:47.840" v="219" actId="478"/>
+          <ac:cxnSpMkLst>
+            <pc:docMk/>
+            <pc:sldMk cId="1915551359" sldId="256"/>
+            <ac:cxnSpMk id="9" creationId="{CE3EC2F5-E818-4AD8-8F7A-4ABC4B98AEEE}"/>
+          </ac:cxnSpMkLst>
+        </pc:cxnChg>
+        <pc:cxnChg chg="del">
+          <ac:chgData name="DOWTY, PETER (DNR)" userId="01cf875a-4e15-4928-8f93-7a0dfa1efb6b" providerId="ADAL" clId="{E9054DD1-CDF4-4BE2-A4C5-BD4B0395A89E}" dt="2026-07-09T13:59:29.394" v="2" actId="478"/>
+          <ac:cxnSpMkLst>
+            <pc:docMk/>
+            <pc:sldMk cId="1915551359" sldId="256"/>
+            <ac:cxnSpMk id="14" creationId="{5357D6B9-AB37-F2D2-06C9-EB97F2F972D6}"/>
+          </ac:cxnSpMkLst>
+        </pc:cxnChg>
+        <pc:cxnChg chg="del">
+          <ac:chgData name="DOWTY, PETER (DNR)" userId="01cf875a-4e15-4928-8f93-7a0dfa1efb6b" providerId="ADAL" clId="{E9054DD1-CDF4-4BE2-A4C5-BD4B0395A89E}" dt="2026-07-09T13:59:30.662" v="3" actId="478"/>
+          <ac:cxnSpMkLst>
+            <pc:docMk/>
+            <pc:sldMk cId="1915551359" sldId="256"/>
+            <ac:cxnSpMk id="23" creationId="{CF439DD9-9643-50C2-9B46-A94D02FA73D1}"/>
+          </ac:cxnSpMkLst>
+        </pc:cxnChg>
+      </pc:sldChg>
+    </pc:docChg>
+  </pc:docChgLst>
+</pc:chgInfo>
 </file>
 
 <file path=ppt/slideLayouts/slideLayout1.xml><?xml version="1.0" encoding="utf-8"?>
@@ -254,7 +416,7 @@
           <a:p>
             <a:fld id="{29A750CF-69B8-4A79-A59C-12BC96DDB93C}" type="datetimeFigureOut">
               <a:rPr lang="en-US" smtClean="0"/>
-              <a:t>7/8/2026</a:t>
+              <a:t>7/9/2026</a:t>
             </a:fld>
             <a:endParaRPr lang="en-US"/>
           </a:p>
@@ -452,7 +614,7 @@
           <a:p>
             <a:fld id="{29A750CF-69B8-4A79-A59C-12BC96DDB93C}" type="datetimeFigureOut">
               <a:rPr lang="en-US" smtClean="0"/>
-              <a:t>7/8/2026</a:t>
+              <a:t>7/9/2026</a:t>
             </a:fld>
             <a:endParaRPr lang="en-US"/>
           </a:p>
@@ -660,7 +822,7 @@
           <a:p>
             <a:fld id="{29A750CF-69B8-4A79-A59C-12BC96DDB93C}" type="datetimeFigureOut">
               <a:rPr lang="en-US" smtClean="0"/>
-              <a:t>7/8/2026</a:t>
+              <a:t>7/9/2026</a:t>
             </a:fld>
             <a:endParaRPr lang="en-US"/>
           </a:p>
@@ -858,7 +1020,7 @@
           <a:p>
             <a:fld id="{29A750CF-69B8-4A79-A59C-12BC96DDB93C}" type="datetimeFigureOut">
               <a:rPr lang="en-US" smtClean="0"/>
-              <a:t>7/8/2026</a:t>
+              <a:t>7/9/2026</a:t>
             </a:fld>
             <a:endParaRPr lang="en-US"/>
           </a:p>
@@ -1133,7 +1295,7 @@
           <a:p>
             <a:fld id="{29A750CF-69B8-4A79-A59C-12BC96DDB93C}" type="datetimeFigureOut">
               <a:rPr lang="en-US" smtClean="0"/>
-              <a:t>7/8/2026</a:t>
+              <a:t>7/9/2026</a:t>
             </a:fld>
             <a:endParaRPr lang="en-US"/>
           </a:p>
@@ -1398,7 +1560,7 @@
           <a:p>
             <a:fld id="{29A750CF-69B8-4A79-A59C-12BC96DDB93C}" type="datetimeFigureOut">
               <a:rPr lang="en-US" smtClean="0"/>
-              <a:t>7/8/2026</a:t>
+              <a:t>7/9/2026</a:t>
             </a:fld>
             <a:endParaRPr lang="en-US"/>
           </a:p>
@@ -1810,7 +1972,7 @@
           <a:p>
             <a:fld id="{29A750CF-69B8-4A79-A59C-12BC96DDB93C}" type="datetimeFigureOut">
               <a:rPr lang="en-US" smtClean="0"/>
-              <a:t>7/8/2026</a:t>
+              <a:t>7/9/2026</a:t>
             </a:fld>
             <a:endParaRPr lang="en-US"/>
           </a:p>
@@ -1951,7 +2113,7 @@
           <a:p>
             <a:fld id="{29A750CF-69B8-4A79-A59C-12BC96DDB93C}" type="datetimeFigureOut">
               <a:rPr lang="en-US" smtClean="0"/>
-              <a:t>7/8/2026</a:t>
+              <a:t>7/9/2026</a:t>
             </a:fld>
             <a:endParaRPr lang="en-US"/>
           </a:p>
@@ -2064,7 +2226,7 @@
           <a:p>
             <a:fld id="{29A750CF-69B8-4A79-A59C-12BC96DDB93C}" type="datetimeFigureOut">
               <a:rPr lang="en-US" smtClean="0"/>
-              <a:t>7/8/2026</a:t>
+              <a:t>7/9/2026</a:t>
             </a:fld>
             <a:endParaRPr lang="en-US"/>
           </a:p>
@@ -2375,7 +2537,7 @@
           <a:p>
             <a:fld id="{29A750CF-69B8-4A79-A59C-12BC96DDB93C}" type="datetimeFigureOut">
               <a:rPr lang="en-US" smtClean="0"/>
-              <a:t>7/8/2026</a:t>
+              <a:t>7/9/2026</a:t>
             </a:fld>
             <a:endParaRPr lang="en-US"/>
           </a:p>
@@ -2663,7 +2825,7 @@
           <a:p>
             <a:fld id="{29A750CF-69B8-4A79-A59C-12BC96DDB93C}" type="datetimeFigureOut">
               <a:rPr lang="en-US" smtClean="0"/>
-              <a:t>7/8/2026</a:t>
+              <a:t>7/9/2026</a:t>
             </a:fld>
             <a:endParaRPr lang="en-US"/>
           </a:p>
@@ -2904,7 +3066,7 @@
           <a:p>
             <a:fld id="{29A750CF-69B8-4A79-A59C-12BC96DDB93C}" type="datetimeFigureOut">
               <a:rPr lang="en-US" smtClean="0"/>
-              <a:t>7/8/2026</a:t>
+              <a:t>7/9/2026</a:t>
             </a:fld>
             <a:endParaRPr lang="en-US"/>
           </a:p>
@@ -3337,18 +3499,33 @@
         </p:nvPicPr>
         <p:blipFill>
           <a:blip r:embed="rId2"/>
+          <a:srcRect b="21127"/>
           <a:stretch>
             <a:fillRect/>
           </a:stretch>
         </p:blipFill>
         <p:spPr>
           <a:xfrm>
-            <a:off x="694343" y="1727097"/>
-            <a:ext cx="4610743" cy="3277057"/>
+            <a:off x="3945458" y="1075247"/>
+            <a:ext cx="4864945" cy="2727209"/>
           </a:xfrm>
           <a:prstGeom prst="rect">
             <a:avLst/>
           </a:prstGeom>
+          <a:ln>
+            <a:solidFill>
+              <a:schemeClr val="bg1">
+                <a:lumMod val="65000"/>
+              </a:schemeClr>
+            </a:solidFill>
+          </a:ln>
+          <a:effectLst>
+            <a:outerShdw blurRad="50800" dist="38100" dir="2700000" algn="tl" rotWithShape="0">
+              <a:prstClr val="black">
+                <a:alpha val="40000"/>
+              </a:prstClr>
+            </a:outerShdw>
+          </a:effectLst>
         </p:spPr>
       </p:pic>
       <p:sp>
@@ -3365,8 +3542,8 @@
         </p:nvSpPr>
         <p:spPr>
           <a:xfrm>
-            <a:off x="1186004" y="1267485"/>
-            <a:ext cx="3883936" cy="307777"/>
+            <a:off x="1892465" y="277898"/>
+            <a:ext cx="7712970" cy="369332"/>
           </a:xfrm>
           <a:prstGeom prst="rect">
             <a:avLst/>
@@ -3380,419 +3557,9 @@
           <a:lstStyle/>
           <a:p>
             <a:r>
-              <a:rPr lang="en-US" sz="1400" dirty="0"/>
-              <a:t>Monitoring recs unmatched with </a:t>
-            </a:r>
-            <a:r>
-              <a:rPr lang="en-US" sz="1400" dirty="0" err="1"/>
-              <a:t>p_gps_pts</a:t>
-            </a:r>
-            <a:r>
-              <a:rPr lang="en-US" sz="1400" dirty="0"/>
-              <a:t> </a:t>
-            </a:r>
-          </a:p>
-        </p:txBody>
-      </p:sp>
-      <p:pic>
-        <p:nvPicPr>
-          <p:cNvPr id="8" name="Picture 7">
-            <a:extLst>
-              <a:ext uri="{FF2B5EF4-FFF2-40B4-BE49-F238E27FC236}">
-                <a16:creationId xmlns:a16="http://schemas.microsoft.com/office/drawing/2014/main" id="{C1DC4500-D4F5-1B2C-3555-1767960B30A3}"/>
-              </a:ext>
-            </a:extLst>
-          </p:cNvPr>
-          <p:cNvPicPr>
-            <a:picLocks noChangeAspect="1"/>
-          </p:cNvPicPr>
-          <p:nvPr/>
-        </p:nvPicPr>
-        <p:blipFill>
-          <a:blip r:embed="rId3"/>
-          <a:stretch>
-            <a:fillRect/>
-          </a:stretch>
-        </p:blipFill>
-        <p:spPr>
-          <a:xfrm>
-            <a:off x="7109727" y="1258391"/>
-            <a:ext cx="3896269" cy="4953691"/>
-          </a:xfrm>
-          <a:prstGeom prst="rect">
-            <a:avLst/>
-          </a:prstGeom>
-        </p:spPr>
-      </p:pic>
-      <p:sp>
-        <p:nvSpPr>
-          <p:cNvPr id="10" name="TextBox 9">
-            <a:extLst>
-              <a:ext uri="{FF2B5EF4-FFF2-40B4-BE49-F238E27FC236}">
-                <a16:creationId xmlns:a16="http://schemas.microsoft.com/office/drawing/2014/main" id="{46F0BEE4-35FB-907E-6845-2623813284AD}"/>
-              </a:ext>
-            </a:extLst>
-          </p:cNvPr>
-          <p:cNvSpPr txBox="1"/>
-          <p:nvPr/>
-        </p:nvSpPr>
-        <p:spPr>
-          <a:xfrm>
-            <a:off x="7109727" y="786142"/>
-            <a:ext cx="3883936" cy="307777"/>
-          </a:xfrm>
-          <a:prstGeom prst="rect">
-            <a:avLst/>
-          </a:prstGeom>
-          <a:noFill/>
-        </p:spPr>
-        <p:txBody>
-          <a:bodyPr wrap="square" rtlCol="0">
-            <a:spAutoFit/>
-          </a:bodyPr>
-          <a:lstStyle/>
-          <a:p>
-            <a:pPr algn="ctr"/>
-            <a:r>
-              <a:rPr lang="en-US" sz="1400" dirty="0" err="1"/>
-              <a:t>p_gps_pts</a:t>
-            </a:r>
-            <a:r>
-              <a:rPr lang="en-US" sz="1400" dirty="0"/>
-              <a:t> </a:t>
-            </a:r>
-          </a:p>
-        </p:txBody>
-      </p:sp>
-      <p:sp>
-        <p:nvSpPr>
-          <p:cNvPr id="11" name="Rectangle 10">
-            <a:extLst>
-              <a:ext uri="{FF2B5EF4-FFF2-40B4-BE49-F238E27FC236}">
-                <a16:creationId xmlns:a16="http://schemas.microsoft.com/office/drawing/2014/main" id="{34A3C746-D7A8-84C1-A7E0-21D276C9840E}"/>
-              </a:ext>
-            </a:extLst>
-          </p:cNvPr>
-          <p:cNvSpPr/>
-          <p:nvPr/>
-        </p:nvSpPr>
-        <p:spPr>
-          <a:xfrm>
-            <a:off x="7251826" y="4092166"/>
-            <a:ext cx="3539905" cy="615636"/>
-          </a:xfrm>
-          <a:prstGeom prst="rect">
-            <a:avLst/>
-          </a:prstGeom>
-          <a:noFill/>
-          <a:ln>
-            <a:solidFill>
-              <a:srgbClr val="FF0000"/>
-            </a:solidFill>
-          </a:ln>
-        </p:spPr>
-        <p:style>
-          <a:lnRef idx="2">
-            <a:schemeClr val="accent1">
-              <a:shade val="15000"/>
-            </a:schemeClr>
-          </a:lnRef>
-          <a:fillRef idx="1">
-            <a:schemeClr val="accent1"/>
-          </a:fillRef>
-          <a:effectRef idx="0">
-            <a:schemeClr val="accent1"/>
-          </a:effectRef>
-          <a:fontRef idx="minor">
-            <a:schemeClr val="lt1"/>
-          </a:fontRef>
-        </p:style>
-        <p:txBody>
-          <a:bodyPr rtlCol="0" anchor="ctr"/>
-          <a:lstStyle/>
-          <a:p>
-            <a:pPr algn="ctr"/>
-            <a:endParaRPr lang="en-US"/>
-          </a:p>
-        </p:txBody>
-      </p:sp>
-      <p:cxnSp>
-        <p:nvCxnSpPr>
-          <p:cNvPr id="14" name="Straight Connector 13">
-            <a:extLst>
-              <a:ext uri="{FF2B5EF4-FFF2-40B4-BE49-F238E27FC236}">
-                <a16:creationId xmlns:a16="http://schemas.microsoft.com/office/drawing/2014/main" id="{5357D6B9-AB37-F2D2-06C9-EB97F2F972D6}"/>
-              </a:ext>
-            </a:extLst>
-          </p:cNvPr>
-          <p:cNvCxnSpPr/>
-          <p:nvPr/>
-        </p:nvCxnSpPr>
-        <p:spPr>
-          <a:xfrm>
-            <a:off x="5604095" y="2362956"/>
-            <a:ext cx="1505632" cy="2037028"/>
-          </a:xfrm>
-          <a:prstGeom prst="line">
-            <a:avLst/>
-          </a:prstGeom>
-          <a:ln>
-            <a:solidFill>
-              <a:srgbClr val="C00000"/>
-            </a:solidFill>
-          </a:ln>
-        </p:spPr>
-        <p:style>
-          <a:lnRef idx="2">
-            <a:schemeClr val="accent1"/>
-          </a:lnRef>
-          <a:fillRef idx="0">
-            <a:schemeClr val="accent1"/>
-          </a:fillRef>
-          <a:effectRef idx="1">
-            <a:schemeClr val="accent1"/>
-          </a:effectRef>
-          <a:fontRef idx="minor">
-            <a:schemeClr val="tx1"/>
-          </a:fontRef>
-        </p:style>
-      </p:cxnSp>
-      <p:pic>
-        <p:nvPicPr>
-          <p:cNvPr id="16" name="Graphic 15" descr="Close with solid fill">
-            <a:extLst>
-              <a:ext uri="{FF2B5EF4-FFF2-40B4-BE49-F238E27FC236}">
-                <a16:creationId xmlns:a16="http://schemas.microsoft.com/office/drawing/2014/main" id="{5CEB1410-6BC8-D8C1-F709-4BBC9D2C958C}"/>
-              </a:ext>
-            </a:extLst>
-          </p:cNvPr>
-          <p:cNvPicPr>
-            <a:picLocks noChangeAspect="1"/>
-          </p:cNvPicPr>
-          <p:nvPr/>
-        </p:nvPicPr>
-        <p:blipFill>
-          <a:blip>
-            <a:extLst>
-              <a:ext uri="{96DAC541-7B7A-43D3-8B79-37D633B846F1}">
-                <asvg:svgBlip xmlns:asvg="http://schemas.microsoft.com/office/drawing/2016/SVG/main" r:embed="rId4"/>
-              </a:ext>
-            </a:extLst>
-          </a:blip>
-          <a:stretch>
-            <a:fillRect/>
-          </a:stretch>
-        </p:blipFill>
-        <p:spPr>
-          <a:xfrm>
-            <a:off x="4732830" y="2679827"/>
-            <a:ext cx="236899" cy="236899"/>
-          </a:xfrm>
-          <a:prstGeom prst="rect">
-            <a:avLst/>
-          </a:prstGeom>
-        </p:spPr>
-      </p:pic>
-      <p:sp>
-        <p:nvSpPr>
-          <p:cNvPr id="20" name="Rectangle 19">
-            <a:extLst>
-              <a:ext uri="{FF2B5EF4-FFF2-40B4-BE49-F238E27FC236}">
-                <a16:creationId xmlns:a16="http://schemas.microsoft.com/office/drawing/2014/main" id="{67FA898A-ADB1-BD7A-6D32-D651D2ED7604}"/>
-              </a:ext>
-            </a:extLst>
-          </p:cNvPr>
-          <p:cNvSpPr/>
-          <p:nvPr/>
-        </p:nvSpPr>
-        <p:spPr>
-          <a:xfrm>
-            <a:off x="6973229" y="4907019"/>
-            <a:ext cx="4610743" cy="461686"/>
-          </a:xfrm>
-          <a:prstGeom prst="rect">
-            <a:avLst/>
-          </a:prstGeom>
-          <a:noFill/>
-          <a:ln>
-            <a:solidFill>
-              <a:srgbClr val="FF0000"/>
-            </a:solidFill>
-          </a:ln>
-        </p:spPr>
-        <p:style>
-          <a:lnRef idx="2">
-            <a:schemeClr val="accent1">
-              <a:shade val="15000"/>
-            </a:schemeClr>
-          </a:lnRef>
-          <a:fillRef idx="1">
-            <a:schemeClr val="accent1"/>
-          </a:fillRef>
-          <a:effectRef idx="0">
-            <a:schemeClr val="accent1"/>
-          </a:effectRef>
-          <a:fontRef idx="minor">
-            <a:schemeClr val="lt1"/>
-          </a:fontRef>
-        </p:style>
-        <p:txBody>
-          <a:bodyPr rtlCol="0" anchor="ctr"/>
-          <a:lstStyle/>
-          <a:p>
-            <a:pPr algn="ctr"/>
-            <a:endParaRPr lang="en-US"/>
-          </a:p>
-        </p:txBody>
-      </p:sp>
-      <p:cxnSp>
-        <p:nvCxnSpPr>
-          <p:cNvPr id="23" name="Straight Connector 22">
-            <a:extLst>
-              <a:ext uri="{FF2B5EF4-FFF2-40B4-BE49-F238E27FC236}">
-                <a16:creationId xmlns:a16="http://schemas.microsoft.com/office/drawing/2014/main" id="{CF439DD9-9643-50C2-9B46-A94D02FA73D1}"/>
-              </a:ext>
-            </a:extLst>
-          </p:cNvPr>
-          <p:cNvCxnSpPr/>
-          <p:nvPr/>
-        </p:nvCxnSpPr>
-        <p:spPr>
-          <a:xfrm>
-            <a:off x="5604095" y="3648547"/>
-            <a:ext cx="1213164" cy="1430447"/>
-          </a:xfrm>
-          <a:prstGeom prst="line">
-            <a:avLst/>
-          </a:prstGeom>
-          <a:ln>
-            <a:solidFill>
-              <a:srgbClr val="C00000"/>
-            </a:solidFill>
-          </a:ln>
-        </p:spPr>
-        <p:style>
-          <a:lnRef idx="2">
-            <a:schemeClr val="accent1"/>
-          </a:lnRef>
-          <a:fillRef idx="0">
-            <a:schemeClr val="accent1"/>
-          </a:fillRef>
-          <a:effectRef idx="1">
-            <a:schemeClr val="accent1"/>
-          </a:effectRef>
-          <a:fontRef idx="minor">
-            <a:schemeClr val="tx1"/>
-          </a:fontRef>
-        </p:style>
-      </p:cxnSp>
-      <p:sp>
-        <p:nvSpPr>
-          <p:cNvPr id="24" name="Rectangle 23">
-            <a:extLst>
-              <a:ext uri="{FF2B5EF4-FFF2-40B4-BE49-F238E27FC236}">
-                <a16:creationId xmlns:a16="http://schemas.microsoft.com/office/drawing/2014/main" id="{FF02E598-D5C0-6007-CF23-974E2CD1FDD7}"/>
-              </a:ext>
-            </a:extLst>
-          </p:cNvPr>
-          <p:cNvSpPr/>
-          <p:nvPr/>
-        </p:nvSpPr>
-        <p:spPr>
-          <a:xfrm>
-            <a:off x="525101" y="2916726"/>
-            <a:ext cx="4864729" cy="1401777"/>
-          </a:xfrm>
-          <a:prstGeom prst="rect">
-            <a:avLst/>
-          </a:prstGeom>
-          <a:noFill/>
-          <a:ln>
-            <a:solidFill>
-              <a:schemeClr val="accent2">
-                <a:lumMod val="40000"/>
-                <a:lumOff val="60000"/>
-              </a:schemeClr>
-            </a:solidFill>
-          </a:ln>
-        </p:spPr>
-        <p:style>
-          <a:lnRef idx="2">
-            <a:schemeClr val="accent1">
-              <a:shade val="15000"/>
-            </a:schemeClr>
-          </a:lnRef>
-          <a:fillRef idx="1">
-            <a:schemeClr val="accent1"/>
-          </a:fillRef>
-          <a:effectRef idx="0">
-            <a:schemeClr val="accent1"/>
-          </a:effectRef>
-          <a:fontRef idx="minor">
-            <a:schemeClr val="lt1"/>
-          </a:fontRef>
-        </p:style>
-        <p:txBody>
-          <a:bodyPr rtlCol="0" anchor="ctr"/>
-          <a:lstStyle/>
-          <a:p>
-            <a:pPr algn="ctr"/>
-            <a:endParaRPr lang="en-US"/>
-          </a:p>
-        </p:txBody>
-      </p:sp>
-      <p:sp>
-        <p:nvSpPr>
-          <p:cNvPr id="26" name="Rectangle 25">
-            <a:extLst>
-              <a:ext uri="{FF2B5EF4-FFF2-40B4-BE49-F238E27FC236}">
-                <a16:creationId xmlns:a16="http://schemas.microsoft.com/office/drawing/2014/main" id="{D22AC38F-7129-62B3-D454-E212F4D7F97C}"/>
-              </a:ext>
-            </a:extLst>
-          </p:cNvPr>
-          <p:cNvSpPr/>
-          <p:nvPr/>
-        </p:nvSpPr>
-        <p:spPr>
-          <a:xfrm>
-            <a:off x="555018" y="2018172"/>
-            <a:ext cx="4864729" cy="661656"/>
-          </a:xfrm>
-          <a:prstGeom prst="rect">
-            <a:avLst/>
-          </a:prstGeom>
-          <a:noFill/>
-          <a:ln>
-            <a:solidFill>
-              <a:schemeClr val="accent2">
-                <a:lumMod val="40000"/>
-                <a:lumOff val="60000"/>
-              </a:schemeClr>
-            </a:solidFill>
-          </a:ln>
-        </p:spPr>
-        <p:style>
-          <a:lnRef idx="2">
-            <a:schemeClr val="accent1">
-              <a:shade val="15000"/>
-            </a:schemeClr>
-          </a:lnRef>
-          <a:fillRef idx="1">
-            <a:schemeClr val="accent1"/>
-          </a:fillRef>
-          <a:effectRef idx="0">
-            <a:schemeClr val="accent1"/>
-          </a:effectRef>
-          <a:fontRef idx="minor">
-            <a:schemeClr val="lt1"/>
-          </a:fontRef>
-        </p:style>
-        <p:txBody>
-          <a:bodyPr rtlCol="0" anchor="ctr"/>
-          <a:lstStyle/>
-          <a:p>
-            <a:pPr algn="ctr"/>
-            <a:endParaRPr lang="en-US"/>
+              <a:rPr lang="en-US" dirty="0"/>
+              <a:t>Monitoring records unmatched with Plantings records (GPS point table)</a:t>
+            </a:r>
           </a:p>
         </p:txBody>
       </p:sp>

</xml_diff>